<commit_message>
Add Swastik Gavhane to report, slides and README
Co-Authored-By: Claude Opus 5.5 <noreply@anthropic.com>
Claude-Session: https://claude.ai/code/session_01HCrX8cVUsejv4DoeVQscMm
</commit_message>
<xml_diff>
--- a/docs/ScholarDesk_CA3.pptx
+++ b/docs/ScholarDesk_CA3.pptx
@@ -115,38 +115,38 @@
   <p:extLst>
     <p:ext uri="{521415D9-36F7-43E2-AB2F-B90AF26B5E84}">
       <p14:sectionLst xmlns:p14="http://schemas.microsoft.com/office/powerpoint/2010/main">
-        <p14:section name="Opening" id="{ddbe320b-583c-1c95-a23c-adf397900942}">
+        <p14:section name="Opening" id="{6da2cb5f-2a4f-4953-71d9-c70c0a1924e1}">
           <p14:sldIdLst>
             <p14:sldId id="256"/>
           </p14:sldIdLst>
         </p14:section>
-        <p14:section name="Problem" id="{5f80ee0b-d8ac-a530-e18d-16f27ec78d6f}">
+        <p14:section name="Problem" id="{1b520e6d-f788-7244-24f0-0340aa2b807e}">
           <p14:sldIdLst>
             <p14:sldId id="257"/>
           </p14:sldIdLst>
         </p14:section>
-        <p14:section name="Solution" id="{5a67a463-601e-c019-0da3-c217769f2a8c}">
+        <p14:section name="Solution" id="{f73aab57-5dff-b364-4c1b-5244da74dccb}">
           <p14:sldIdLst>
             <p14:sldId id="258"/>
           </p14:sldIdLst>
         </p14:section>
-        <p14:section name="Architecture" id="{a8a5c049-3b81-631c-5d24-43b624c852c9}">
+        <p14:section name="Architecture" id="{f3ee0c1e-3127-137a-33e3-4b30301d88e0}">
           <p14:sldIdLst>
             <p14:sldId id="259"/>
             <p14:sldId id="260"/>
           </p14:sldIdLst>
         </p14:section>
-        <p14:section name="Demo" id="{8ee20ec4-2ad5-763e-833a-d8bc56323aa0}">
+        <p14:section name="Demo" id="{e2ceabb6-9762-af19-aab9-a7716dbb77c4}">
           <p14:sldIdLst>
             <p14:sldId id="261"/>
           </p14:sldIdLst>
         </p14:section>
-        <p14:section name="Results" id="{afc9295d-b868-ff9b-87b1-84aa089ead77}">
+        <p14:section name="Results" id="{d2d3cf13-9eaf-0bae-6763-0d2f05939a0f}">
           <p14:sldIdLst>
             <p14:sldId id="262"/>
           </p14:sldIdLst>
         </p14:section>
-        <p14:section name="Close" id="{39b050fb-39f1-4dd8-e8d6-218ee5e514ad}">
+        <p14:section name="Close" id="{ee517c00-449d-b443-a7b7-5a7216b28513}">
           <p14:sldIdLst>
             <p14:sldId id="263"/>
             <p14:sldId id="264"/>
@@ -866,7 +866,7 @@
           <a:p>
             <a:r>
               <a:rPr lang="en-US" dirty="0"/>
-              <a:t>Hi, I'm Saafalya. My project is the Scholarship Screening Desk, an agentic AI proof of concept in the education domain. It uses six agents to screen scholarship applications the way a college office does, but with every rule checked and every decision explained.</a:t>
+              <a:t>Hi, we're Saafalya and Swastik. Our project is the Scholarship Screening Desk, an agentic AI proof of concept in the education domain. It uses six agents to screen scholarship applications the way a college office does, but with every rule checked and every decision explained.</a:t>
             </a:r>
             <a:endParaRPr lang="en-US" dirty="0"/>
           </a:p>
@@ -1845,7 +1845,7 @@
                   <a:schemeClr val="tx2"/>
                 </a:solidFill>
               </a:rPr>
-              <a:t>Scholarship Screening Desk · Saafalya Sengupta · AIML C1</a:t>
+              <a:t>Scholarship Screening Desk · Saafalya Sengupta &amp; Swastik Gavhane · AIML C1</a:t>
             </a:r>
             <a:endParaRPr lang="en-US" sz="900" dirty="0"/>
           </a:p>
@@ -2416,8 +2416,8 @@
         </p:nvSpPr>
         <p:spPr>
           <a:xfrm>
-            <a:off x="548640" y="4069080"/>
-            <a:ext cx="5943600" cy="548640"/>
+            <a:off x="548640" y="3749040"/>
+            <a:ext cx="5943600" cy="868680"/>
           </a:xfrm>
           <a:prstGeom prst="rect">
             <a:avLst/>
@@ -2438,7 +2438,7 @@
                   <a:srgbClr val="FFFFFF"/>
                 </a:solidFill>
               </a:rPr>
-              <a:t>Saafalya Sengupta</a:t>
+              <a:t>Saafalya Sengupta · PRN 24070126158</a:t>
             </a:r>
             <a:endParaRPr lang="en-US" sz="1300" dirty="0"/>
           </a:p>
@@ -2447,12 +2447,26 @@
               <a:buNone/>
             </a:pPr>
             <a:r>
+              <a:rPr lang="en-US" sz="1300" b="1" dirty="0">
+                <a:solidFill>
+                  <a:srgbClr val="FFFFFF"/>
+                </a:solidFill>
+              </a:rPr>
+              <a:t>Swastik Gavhane · PRN 24070126224</a:t>
+            </a:r>
+            <a:endParaRPr lang="en-US" sz="1300" dirty="0"/>
+          </a:p>
+          <a:p>
+            <a:pPr indent="0" marL="0">
+              <a:buNone/>
+            </a:pPr>
+            <a:r>
               <a:rPr lang="en-US" sz="1300" dirty="0">
                 <a:solidFill>
                   <a:srgbClr val="C9D2DE"/>
                 </a:solidFill>
               </a:rPr>
-              <a:t>PRN 24070126158 · AIML C1 · CA-3 Agentic AI PoC</a:t>
+              <a:t>AIML C1 · CA-3 Agentic AI PoC</a:t>
             </a:r>
             <a:endParaRPr lang="en-US" sz="1300" dirty="0"/>
           </a:p>
@@ -2466,7 +2480,7 @@
         </p:nvSpPr>
         <p:spPr>
           <a:xfrm>
-            <a:off x="6629400" y="4206240"/>
+            <a:off x="6629400" y="4343400"/>
             <a:ext cx="2011680" cy="274320"/>
           </a:xfrm>
           <a:prstGeom prst="rect">

</xml_diff>

<commit_message>
Refresh report and slides for the local Ollama version; small UI fixes
Co-Authored-By: Claude Opus 5.5 <noreply@anthropic.com>
Claude-Session: https://claude.ai/code/session_01HCrX8cVUsejv4DoeVQscMm
</commit_message>
<xml_diff>
--- a/docs/ScholarDesk_CA3.pptx
+++ b/docs/ScholarDesk_CA3.pptx
@@ -115,38 +115,38 @@
   <p:extLst>
     <p:ext uri="{521415D9-36F7-43E2-AB2F-B90AF26B5E84}">
       <p14:sectionLst xmlns:p14="http://schemas.microsoft.com/office/powerpoint/2010/main">
-        <p14:section name="Opening" id="{6da2cb5f-2a4f-4953-71d9-c70c0a1924e1}">
+        <p14:section name="Opening" id="{e027737f-7b24-c92a-9243-04e4e0b2e7cf}">
           <p14:sldIdLst>
             <p14:sldId id="256"/>
           </p14:sldIdLst>
         </p14:section>
-        <p14:section name="Problem" id="{1b520e6d-f788-7244-24f0-0340aa2b807e}">
+        <p14:section name="Problem" id="{4469ce80-3277-2901-7a18-2224867e7c44}">
           <p14:sldIdLst>
             <p14:sldId id="257"/>
           </p14:sldIdLst>
         </p14:section>
-        <p14:section name="Solution" id="{f73aab57-5dff-b364-4c1b-5244da74dccb}">
+        <p14:section name="Solution" id="{fdff4c6f-bf04-fba4-7735-4fa6ea882739}">
           <p14:sldIdLst>
             <p14:sldId id="258"/>
           </p14:sldIdLst>
         </p14:section>
-        <p14:section name="Architecture" id="{f3ee0c1e-3127-137a-33e3-4b30301d88e0}">
+        <p14:section name="Architecture" id="{a3440e74-24cc-02fa-4510-e64e10dbe870}">
           <p14:sldIdLst>
             <p14:sldId id="259"/>
             <p14:sldId id="260"/>
           </p14:sldIdLst>
         </p14:section>
-        <p14:section name="Demo" id="{e2ceabb6-9762-af19-aab9-a7716dbb77c4}">
+        <p14:section name="Demo" id="{a66cfef4-927e-bb9a-89ef-4655426130eb}">
           <p14:sldIdLst>
             <p14:sldId id="261"/>
           </p14:sldIdLst>
         </p14:section>
-        <p14:section name="Results" id="{d2d3cf13-9eaf-0bae-6763-0d2f05939a0f}">
+        <p14:section name="Results" id="{aefc3a8f-e95b-ce75-02d3-f996bd880e78}">
           <p14:sldIdLst>
             <p14:sldId id="262"/>
           </p14:sldIdLst>
         </p14:section>
-        <p14:section name="Close" id="{ee517c00-449d-b443-a7b7-5a7216b28513}">
+        <p14:section name="Close" id="{f62196ab-5142-7197-961f-1ef6d091ca55}">
           <p14:sldIdLst>
             <p14:sldId id="263"/>
             <p14:sldId id="264"/>
@@ -1306,7 +1306,7 @@
           <a:p>
             <a:r>
               <a:rPr lang="en-US" dirty="0"/>
-              <a:t>Switch to the app now. Pick MCM-2026-002, turn on 'Make the Extractor slip once', and press Screen. Point at the trace: the Critic finds a mismatch, the orchestrator sends it back, the Extractor re-reads and the Critic accepts. Then the Validator runs six tools. Five pass, but the form says CGPA 8.40 while the marksheet says 7.70, so it's not eligible. Then switch to the batch tab, set four awards, and screen all twelve.</a:t>
+              <a:t>Switch to the app. First point at the sidebar: Ollama is running with llama3.2:3b, and Test the model loads it. Screen any application and watch the six tiles light up; each trace step has a badge saying whether Ollama, the rule model or plain Python did it, with the time. Then pick MCM-2026-002 with 'Make the Extractor slip once' on, using the rule model, to show the Critic sending the case back. Finally open the Paste tab: the plain-language application says income is about 3.2 lakh a year. The rule model can't read it, Ollama can, and the Critic confirms 3.2 lakh is in the text.</a:t>
             </a:r>
             <a:endParaRPr lang="en-US" dirty="0"/>
           </a:p>
@@ -1570,7 +1570,7 @@
           <a:p>
             <a:r>
               <a:rPr lang="en-US" dirty="0"/>
-              <a:t>Thank you. The app is live on Render and the code is on GitHub. Happy to take questions.</a:t>
+              <a:t>Thank you. The app runs locally with Ollama from one launcher, and the code is on GitHub. Happy to take questions.</a:t>
             </a:r>
             <a:endParaRPr lang="en-US" dirty="0"/>
           </a:p>
@@ -3714,7 +3714,7 @@
                   <a:schemeClr val="tx1"/>
                 </a:solidFill>
               </a:rPr>
-              <a:t>Re-reads the source, sends wrong extractions back, checks the final verdict</a:t>
+              <a:t>Checks every number against the source, sends wrong fields back, checks the verdict</a:t>
             </a:r>
             <a:endParaRPr lang="en-US" sz="1300" dirty="0"/>
           </a:p>
@@ -5632,7 +5632,7 @@
                   <a:schemeClr val="tx1"/>
                 </a:solidFill>
               </a:rPr>
-              <a:t>Demo: the Critic catches a slip</a:t>
+              <a:t>Demo: live agents on a local model</a:t>
             </a:r>
             <a:endParaRPr lang="en-US" sz="2600" dirty="0"/>
           </a:p>
@@ -5640,7 +5640,7 @@
       </p:sp>
       <p:pic>
         <p:nvPicPr>
-          <p:cNvPr id="3" name="demo-shot" descr="Screenshot of the app screening application MCM-2026-002 with a NOT ELIGIBLE stamp, rule checks and the agent trace">    </p:cNvPr>
+          <p:cNvPr id="3" name="demo-shot" descr="Screenshot of the app: NOT ELIGIBLE stamp, rule checks, and six agent tiles with the Critic tile in amber after a send-back">    </p:cNvPr>
           <p:cNvPicPr>
             <a:picLocks noChangeAspect="1"/>
           </p:cNvPicPr>
@@ -5654,8 +5654,8 @@
         </p:blipFill>
         <p:spPr>
           <a:xfrm>
-            <a:off x="457200" y="1051560"/>
-            <a:ext cx="3291840" cy="3529584"/>
+            <a:off x="457200" y="1024128"/>
+            <a:ext cx="2194560" cy="3602736"/>
           </a:xfrm>
           <a:prstGeom prst="rect">
             <a:avLst/>
@@ -5670,7 +5670,7 @@
         </p:nvSpPr>
         <p:spPr>
           <a:xfrm>
-            <a:off x="4023360" y="1051560"/>
+            <a:off x="2971800" y="1051560"/>
             <a:ext cx="384048" cy="384048"/>
           </a:xfrm>
           <a:prstGeom prst="ellipse">
@@ -5690,7 +5690,7 @@
         </p:nvSpPr>
         <p:spPr>
           <a:xfrm>
-            <a:off x="4023360" y="1051560"/>
+            <a:off x="2971800" y="1051560"/>
             <a:ext cx="384048" cy="384048"/>
           </a:xfrm>
           <a:prstGeom prst="rect">
@@ -5726,8 +5726,8 @@
         </p:nvSpPr>
         <p:spPr>
           <a:xfrm>
-            <a:off x="4572000" y="996696"/>
-            <a:ext cx="4114800" cy="822960"/>
+            <a:off x="3520440" y="996696"/>
+            <a:ext cx="5120640" cy="822960"/>
           </a:xfrm>
           <a:prstGeom prst="rect">
             <a:avLst/>
@@ -5748,7 +5748,7 @@
                   <a:srgbClr val="000000"/>
                 </a:solidFill>
               </a:rPr>
-              <a:t>Pick an application</a:t>
+              <a:t>Check the model</a:t>
             </a:r>
             <a:endParaRPr lang="en-US" sz="1500" dirty="0"/>
           </a:p>
@@ -5762,7 +5762,7 @@
                   <a:schemeClr val="tx2"/>
                 </a:solidFill>
               </a:rPr>
-              <a:t>MCM-2026-002, Rohan Deshmukh, OBC. The demo switch makes the Extractor slip once.</a:t>
+              <a:t>The sidebar shows Ollama running with llama3.2:3b. Test the model loads it before the first case.</a:t>
             </a:r>
             <a:endParaRPr lang="en-US" sz="1500" dirty="0"/>
           </a:p>
@@ -5776,7 +5776,7 @@
         </p:nvSpPr>
         <p:spPr>
           <a:xfrm>
-            <a:off x="4023360" y="1947672"/>
+            <a:off x="2971800" y="1947672"/>
             <a:ext cx="384048" cy="384048"/>
           </a:xfrm>
           <a:prstGeom prst="ellipse">
@@ -5796,7 +5796,7 @@
         </p:nvSpPr>
         <p:spPr>
           <a:xfrm>
-            <a:off x="4023360" y="1947672"/>
+            <a:off x="2971800" y="1947672"/>
             <a:ext cx="384048" cy="384048"/>
           </a:xfrm>
           <a:prstGeom prst="rect">
@@ -5832,8 +5832,8 @@
         </p:nvSpPr>
         <p:spPr>
           <a:xfrm>
-            <a:off x="4572000" y="1892808"/>
-            <a:ext cx="4114800" cy="822960"/>
+            <a:off x="3520440" y="1892808"/>
+            <a:ext cx="5120640" cy="822960"/>
           </a:xfrm>
           <a:prstGeom prst="rect">
             <a:avLst/>
@@ -5854,7 +5854,7 @@
                   <a:srgbClr val="000000"/>
                 </a:solidFill>
               </a:rPr>
-              <a:t>Critic sends it back</a:t>
+              <a:t>Watch the agents work</a:t>
             </a:r>
             <a:endParaRPr lang="en-US" sz="1500" dirty="0"/>
           </a:p>
@@ -5868,7 +5868,7 @@
                   <a:schemeClr val="tx2"/>
                 </a:solidFill>
               </a:rPr>
-              <a:t>Trace steps 3–6: the Critic spots a wrong field, the Extractor re-reads, the Critic accepts.</a:t>
+              <a:t>Six tiles light up as each agent runs. Every trace step shows Ollama, rule model or Python, and its time.</a:t>
             </a:r>
             <a:endParaRPr lang="en-US" sz="1500" dirty="0"/>
           </a:p>
@@ -5882,7 +5882,7 @@
         </p:nvSpPr>
         <p:spPr>
           <a:xfrm>
-            <a:off x="4023360" y="2843784"/>
+            <a:off x="2971800" y="2843784"/>
             <a:ext cx="384048" cy="384048"/>
           </a:xfrm>
           <a:prstGeom prst="ellipse">
@@ -5902,7 +5902,7 @@
         </p:nvSpPr>
         <p:spPr>
           <a:xfrm>
-            <a:off x="4023360" y="2843784"/>
+            <a:off x="2971800" y="2843784"/>
             <a:ext cx="384048" cy="384048"/>
           </a:xfrm>
           <a:prstGeom prst="rect">
@@ -5938,8 +5938,8 @@
         </p:nvSpPr>
         <p:spPr>
           <a:xfrm>
-            <a:off x="4572000" y="2788920"/>
-            <a:ext cx="4114800" cy="822960"/>
+            <a:off x="3520440" y="2788920"/>
+            <a:ext cx="5120640" cy="822960"/>
           </a:xfrm>
           <a:prstGeom prst="rect">
             <a:avLst/>
@@ -5960,7 +5960,7 @@
                   <a:srgbClr val="000000"/>
                 </a:solidFill>
               </a:rPr>
-              <a:t>Validator runs six tools</a:t>
+              <a:t>Critic catches a slip</a:t>
             </a:r>
             <a:endParaRPr lang="en-US" sz="1500" dirty="0"/>
           </a:p>
@@ -5974,7 +5974,7 @@
                   <a:schemeClr val="tx2"/>
                 </a:solidFill>
               </a:rPr>
-              <a:t>Five pass. check_consistency fails: form says 8.40, marksheet says 7.70.</a:t>
+              <a:t>MCM-2026-002 with the demo switch: the Critic sends it back, then the CGPA mismatch fails.</a:t>
             </a:r>
             <a:endParaRPr lang="en-US" sz="1500" dirty="0"/>
           </a:p>
@@ -5988,7 +5988,7 @@
         </p:nvSpPr>
         <p:spPr>
           <a:xfrm>
-            <a:off x="4023360" y="3739896"/>
+            <a:off x="2971800" y="3739896"/>
             <a:ext cx="384048" cy="384048"/>
           </a:xfrm>
           <a:prstGeom prst="ellipse">
@@ -6008,7 +6008,7 @@
         </p:nvSpPr>
         <p:spPr>
           <a:xfrm>
-            <a:off x="4023360" y="3739896"/>
+            <a:off x="2971800" y="3739896"/>
             <a:ext cx="384048" cy="384048"/>
           </a:xfrm>
           <a:prstGeom prst="rect">
@@ -6044,8 +6044,8 @@
         </p:nvSpPr>
         <p:spPr>
           <a:xfrm>
-            <a:off x="4572000" y="3685032"/>
-            <a:ext cx="4114800" cy="822960"/>
+            <a:off x="3520440" y="3685032"/>
+            <a:ext cx="5120640" cy="822960"/>
           </a:xfrm>
           <a:prstGeom prst="rect">
             <a:avLst/>
@@ -6066,7 +6066,7 @@
                   <a:srgbClr val="000000"/>
                 </a:solidFill>
               </a:rPr>
-              <a:t>Stamp and reason</a:t>
+              <a:t>Paste plain language</a:t>
             </a:r>
             <a:endParaRPr lang="en-US" sz="1500" dirty="0"/>
           </a:p>
@@ -6080,7 +6080,7 @@
                   <a:schemeClr val="tx2"/>
                 </a:solidFill>
               </a:rPr>
-              <a:t>Not eligible, with the exact rule named for the reviewer.</a:t>
+              <a:t>“Earns about 3.2 lakh a year”: the rule model can't read it, Ollama can, the Critic checks it.</a:t>
             </a:r>
             <a:endParaRPr lang="en-US" sz="1500" dirty="0"/>
           </a:p>
@@ -6088,16 +6088,14 @@
       </p:sp>
       <p:sp>
         <p:nvSpPr>
-          <p:cNvPr id="16" name="demo-link">
-            <a:hlinkClick r:id="rId2" tooltip=""/>
-          </p:cNvPr>
+          <p:cNvPr id="16" name="demo-link"/>
           <p:cNvSpPr txBox="1"/>
           <p:nvPr/>
         </p:nvSpPr>
         <p:spPr>
           <a:xfrm>
-            <a:off x="4572000" y="4526280"/>
-            <a:ext cx="4114800" cy="228600"/>
+            <a:off x="3520440" y="4526280"/>
+            <a:ext cx="5120640" cy="228600"/>
           </a:xfrm>
           <a:prstGeom prst="rect">
             <a:avLst/>
@@ -6113,19 +6111,12 @@
               <a:buNone/>
             </a:pPr>
             <a:r>
-              <a:rPr lang="en-US" sz="1100" b="1" u="sng" dirty="0">
+              <a:rPr lang="en-US" sz="1100" b="1" dirty="0">
                 <a:solidFill>
                   <a:schemeClr val="accent2"/>
                 </a:solidFill>
-                <a:hlinkClick r:id="rId2" invalidUrl="" action="" tgtFrame="" tooltip="" history="1" highlightClick="0" endSnd="0">
-                  <a:extLst>
-                    <a:ext uri="{A12FA001-AC4F-418D-AE19-62706E023703}">
-                      <ahyp:hlinkClr xmlns:ahyp="http://schemas.microsoft.com/office/drawing/2018/hyperlinkcolor" val="tx"/>
-                    </a:ext>
-                  </a:extLst>
-                </a:hlinkClick>
-              </a:rPr>
-              <a:t>Live: scholardesk-wpdp.onrender.com</a:t>
+              </a:rPr>
+              <a:t>Runs locally: double-click run_windows.bat</a:t>
             </a:r>
             <a:endParaRPr lang="en-US" sz="1100" dirty="0"/>
           </a:p>
@@ -7226,49 +7217,42 @@
                   <a:srgbClr val="C9D2DE"/>
                 </a:solidFill>
               </a:rPr>
-              <a:t>Live app  </a:t>
+              <a:t>Run it  </a:t>
             </a:r>
             <a:pPr indent="0" marL="0">
               <a:buNone/>
             </a:pPr>
             <a:r>
+              <a:rPr lang="en-US" sz="1400" b="1" dirty="0">
+                <a:solidFill>
+                  <a:srgbClr val="FFFFFF"/>
+                </a:solidFill>
+              </a:rPr>
+              <a:t>run_windows.bat · Streamlit + Ollama on the laptop</a:t>
+            </a:r>
+            <a:endParaRPr lang="en-US" sz="1400" dirty="0"/>
+          </a:p>
+          <a:p>
+            <a:pPr indent="0" marL="0">
+              <a:buNone/>
+            </a:pPr>
+            <a:r>
+              <a:rPr lang="en-US" sz="1400" dirty="0">
+                <a:solidFill>
+                  <a:srgbClr val="C9D2DE"/>
+                </a:solidFill>
+              </a:rPr>
+              <a:t>Code  </a:t>
+            </a:r>
+            <a:pPr indent="0" marL="0">
+              <a:buNone/>
+            </a:pPr>
+            <a:r>
               <a:rPr lang="en-US" sz="1400" b="1" u="sng" dirty="0">
                 <a:solidFill>
                   <a:srgbClr val="FFFFFF"/>
                 </a:solidFill>
                 <a:hlinkClick r:id="rId1" invalidUrl="" action="" tgtFrame="" tooltip="" history="1" highlightClick="0" endSnd="0">
-                  <a:extLst>
-                    <a:ext uri="{A12FA001-AC4F-418D-AE19-62706E023703}">
-                      <ahyp:hlinkClr xmlns:ahyp="http://schemas.microsoft.com/office/drawing/2018/hyperlinkcolor" val="tx"/>
-                    </a:ext>
-                  </a:extLst>
-                </a:hlinkClick>
-              </a:rPr>
-              <a:t>scholardesk-wpdp.onrender.com</a:t>
-            </a:r>
-            <a:endParaRPr lang="en-US" sz="1400" dirty="0"/>
-          </a:p>
-          <a:p>
-            <a:pPr indent="0" marL="0">
-              <a:buNone/>
-            </a:pPr>
-            <a:r>
-              <a:rPr lang="en-US" sz="1400" dirty="0">
-                <a:solidFill>
-                  <a:srgbClr val="C9D2DE"/>
-                </a:solidFill>
-              </a:rPr>
-              <a:t>Code  </a:t>
-            </a:r>
-            <a:pPr indent="0" marL="0">
-              <a:buNone/>
-            </a:pPr>
-            <a:r>
-              <a:rPr lang="en-US" sz="1400" b="1" u="sng" dirty="0">
-                <a:solidFill>
-                  <a:srgbClr val="FFFFFF"/>
-                </a:solidFill>
-                <a:hlinkClick r:id="rId2" invalidUrl="" action="" tgtFrame="" tooltip="" history="1" highlightClick="0" endSnd="0">
                   <a:extLst>
                     <a:ext uri="{A12FA001-AC4F-418D-AE19-62706E023703}">
                       <ahyp:hlinkClr xmlns:ahyp="http://schemas.microsoft.com/office/drawing/2018/hyperlinkcolor" val="tx"/>

</xml_diff>